<commit_message>
land-life-proposal: Japan Management edition uses the official company info
Company name is 合同会社JAPANマネジメント (not 株式会社), with address, TEL
03-6914-4887, hours and closing days from the 会社情報 on japan-mgmt.co.jp.
P24 and the proposal PDF now show address/hours/closed when an edition sets
them. Specs added first (TDD): npm test 30 passing.

Co-Authored-By: Claude Opus 5.5 <noreply@anthropic.com>
Claude-Session: https://claude.ai/code/session_01UqxcrjN99bqTjC6tGASVQe
</commit_message>
<xml_diff>
--- a/land-life-proposal/dist/japan-mgmt/人生を、自分の土地から。_ジャパンマネジメント版.pptx
+++ b/land-life-proposal/dist/japan-mgmt/人生を、自分の土地から。_ジャパンマネジメント版.pptx
@@ -130,7 +130,7 @@
   <p:extLst>
     <p:ext uri="{521415D9-36F7-43E2-AB2F-B90AF26B5E84}">
       <p14:sectionLst xmlns:p14="http://schemas.microsoft.com/office/powerpoint/2010/main">
-        <p14:section name="第1幕 憧れ" id="{197b1454-8050-6835-786b-2e60b89e2582}">
+        <p14:section name="第1幕 憧れ" id="{8507f833-3cee-d27c-d7bb-6d2c3d34e858}">
           <p14:sldIdLst>
             <p14:sldId id="256"/>
             <p14:sldId id="257"/>
@@ -138,7 +138,7 @@
             <p14:sldId id="259"/>
           </p14:sldIdLst>
         </p14:section>
-        <p14:section name="第2幕 発見" id="{a1029063-8081-9c28-7703-9003944e7f03}">
+        <p14:section name="第2幕 発見" id="{765e5468-cba0-a088-f6a6-494afdf3d387}">
           <p14:sldIdLst>
             <p14:sldId id="260"/>
             <p14:sldId id="261"/>
@@ -148,7 +148,7 @@
             <p14:sldId id="265"/>
           </p14:sldIdLst>
         </p14:section>
-        <p14:section name="第3幕 納得" id="{050e04a2-141b-1b25-34fa-243fccce524d}">
+        <p14:section name="第3幕 納得" id="{6a9dbffc-8c38-dc4d-2c24-5fab7333c784}">
           <p14:sldIdLst>
             <p14:sldId id="266"/>
             <p14:sldId id="267"/>
@@ -158,7 +158,7 @@
             <p14:sldId id="271"/>
           </p14:sldIdLst>
         </p14:section>
-        <p14:section name="第4幕 安心" id="{516972c9-c98f-9dc1-1b27-1952c0fc0149}">
+        <p14:section name="第4幕 安心" id="{9e2a155a-29f8-0184-a474-a6e5a908144b}">
           <p14:sldIdLst>
             <p14:sldId id="272"/>
             <p14:sldId id="273"/>
@@ -167,7 +167,7 @@
             <p14:sldId id="276"/>
           </p14:sldIdLst>
         </p14:section>
-        <p14:section name="第5幕 行動" id="{28e87b7b-bf0a-8264-50da-ca31fbf25e63}">
+        <p14:section name="第5幕 行動" id="{5944f29a-0236-b9e2-6e04-26b220730a99}">
           <p14:sldIdLst>
             <p14:sldId id="277"/>
             <p14:sldId id="278"/>
@@ -183,7 +183,7 @@
 </p:presentation>
 </file>
 
-<file path=ppt/charts/chart4.xml><?xml version="1.0" encoding="utf-8"?>
+<file path=ppt/charts/chart1.xml><?xml version="1.0" encoding="utf-8"?>
 <c:chartSpace xmlns:c="http://schemas.openxmlformats.org/drawingml/2006/chart" xmlns:a="http://schemas.openxmlformats.org/drawingml/2006/main" xmlns:r="http://schemas.openxmlformats.org/officeDocument/2006/relationships">
   <c:date1904 val="0"/>
   <c:roundedCorners val="1"/>
@@ -650,7 +650,7 @@
 </c:chartSpace>
 </file>
 
-<file path=ppt/charts/chart5.xml><?xml version="1.0" encoding="utf-8"?>
+<file path=ppt/charts/chart2.xml><?xml version="1.0" encoding="utf-8"?>
 <c:chartSpace xmlns:c="http://schemas.openxmlformats.org/drawingml/2006/chart" xmlns:a="http://schemas.openxmlformats.org/drawingml/2006/main" xmlns:r="http://schemas.openxmlformats.org/officeDocument/2006/relationships">
   <c:date1904 val="0"/>
   <c:roundedCorners val="1"/>
@@ -1289,7 +1289,7 @@
 </c:chartSpace>
 </file>
 
-<file path=ppt/charts/chart6.xml><?xml version="1.0" encoding="utf-8"?>
+<file path=ppt/charts/chart3.xml><?xml version="1.0" encoding="utf-8"?>
 <c:chartSpace xmlns:c="http://schemas.openxmlformats.org/drawingml/2006/chart" xmlns:a="http://schemas.openxmlformats.org/drawingml/2006/main" xmlns:r="http://schemas.openxmlformats.org/officeDocument/2006/relationships">
   <c:date1904 val="0"/>
   <c:roundedCorners val="1"/>
@@ -5561,7 +5561,7 @@
                 <a:ea typeface="Yu Gothic" pitchFamily="34" charset="-122"/>
                 <a:cs typeface="Yu Gothic" pitchFamily="34" charset="-120"/>
               </a:rPr>
-              <a:t>株式会社ジャパンマネジメント</a:t>
+              <a:t>合同会社JAPANマネジメント</a:t>
             </a:r>
             <a:endParaRPr lang="en-US" sz="900" dirty="0"/>
           </a:p>
@@ -5803,7 +5803,7 @@
                 <a:ea typeface="Yu Gothic" pitchFamily="34" charset="-122"/>
                 <a:cs typeface="Yu Gothic" pitchFamily="34" charset="-120"/>
               </a:rPr>
-              <a:t>株式会社ジャパンマネジメント</a:t>
+              <a:t>合同会社JAPANマネジメント</a:t>
             </a:r>
             <a:endParaRPr lang="en-US" sz="900" dirty="0"/>
           </a:p>
@@ -6708,7 +6708,7 @@
                 <a:ea typeface="Yu Gothic" pitchFamily="34" charset="-122"/>
                 <a:cs typeface="Yu Gothic" pitchFamily="34" charset="-120"/>
               </a:rPr>
-              <a:t>株式会社ジャパンマネジメント</a:t>
+              <a:t>合同会社JAPANマネジメント</a:t>
             </a:r>
             <a:endParaRPr lang="en-US" sz="1400" dirty="0"/>
           </a:p>
@@ -24209,7 +24209,7 @@
                 <a:ea typeface="Yu Gothic" pitchFamily="34" charset="-122"/>
                 <a:cs typeface="Yu Gothic" pitchFamily="34" charset="-120"/>
               </a:rPr>
-              <a:t>株式会社ジャパンマネジメント</a:t>
+              <a:t>合同会社JAPANマネジメント</a:t>
             </a:r>
             <a:endParaRPr lang="en-US" sz="900" dirty="0"/>
           </a:p>
@@ -31006,7 +31006,7 @@
         <p:spPr>
           <a:xfrm>
             <a:off x="640080" y="5212080"/>
-            <a:ext cx="5486400" cy="365760"/>
+            <a:ext cx="4754880" cy="365760"/>
           </a:xfrm>
           <a:prstGeom prst="rect">
             <a:avLst/>
@@ -31030,7 +31030,7 @@
                 <a:ea typeface="Yu Gothic" pitchFamily="34" charset="-122"/>
                 <a:cs typeface="Yu Gothic" pitchFamily="34" charset="-120"/>
               </a:rPr>
-              <a:t>株式会社ジャパンマネジメント</a:t>
+              <a:t>合同会社JAPANマネジメント</a:t>
             </a:r>
             <a:endParaRPr lang="en-US" sz="1800" dirty="0"/>
           </a:p>
@@ -31044,8 +31044,47 @@
         </p:nvSpPr>
         <p:spPr>
           <a:xfrm>
+            <a:off x="5486400" y="5212080"/>
+            <a:ext cx="6065215" cy="365760"/>
+          </a:xfrm>
+          <a:prstGeom prst="rect">
+            <a:avLst/>
+          </a:prstGeom>
+          <a:noFill/>
+          <a:ln/>
+        </p:spPr>
+        <p:txBody>
+          <a:bodyPr wrap="square" lIns="0" tIns="0" rIns="0" bIns="0" rtlCol="0" anchor="ctr"/>
+          <a:lstStyle/>
+          <a:p>
+            <a:pPr algn="r" indent="0" marL="0">
+              <a:buNone/>
+            </a:pPr>
+            <a:r>
+              <a:rPr lang="en-US" sz="1100" dirty="0">
+                <a:solidFill>
+                  <a:srgbClr val="EADFCB"/>
+                </a:solidFill>
+                <a:latin typeface="Yu Gothic" pitchFamily="34" charset="0"/>
+                <a:ea typeface="Yu Gothic" pitchFamily="34" charset="-122"/>
+                <a:cs typeface="Yu Gothic" pitchFamily="34" charset="-120"/>
+              </a:rPr>
+              <a:t>お金の不安をなくすことは、人生の自由を取り戻すこと。住宅と家計・老後資金をまとめてご相談いただけます。</a:t>
+            </a:r>
+            <a:endParaRPr lang="en-US" sz="1100" dirty="0"/>
+          </a:p>
+        </p:txBody>
+      </p:sp>
+      <p:sp>
+        <p:nvSpPr>
+          <p:cNvPr id="29" name="Text 22"/>
+          <p:cNvSpPr txBox="1"/>
+          <p:nvPr/>
+        </p:nvSpPr>
+        <p:spPr>
+          <a:xfrm>
             <a:off x="640080" y="5577840"/>
-            <a:ext cx="7315200" cy="274320"/>
+            <a:ext cx="10911535" cy="256032"/>
           </a:xfrm>
           <a:prstGeom prst="rect">
             <a:avLst/>
@@ -31069,7 +31108,7 @@
                 <a:ea typeface="Yu Gothic" pitchFamily="34" charset="-122"/>
                 <a:cs typeface="Yu Gothic" pitchFamily="34" charset="-120"/>
               </a:rPr>
-              <a:t>japan-mgmt.co.jp　TEL 〔要確認〕　担当：＿＿＿＿＿＿</a:t>
+              <a:t>〒186-0011 東京都国立市谷保四丁目20-1 JUNメビウス国立1F　TEL 03-6914-4887　japan-mgmt.co.jp</a:t>
             </a:r>
             <a:endParaRPr lang="en-US" sz="1200" dirty="0"/>
           </a:p>
@@ -31077,7 +31116,7 @@
       </p:sp>
       <p:sp>
         <p:nvSpPr>
-          <p:cNvPr id="29" name="Text 22"/>
+          <p:cNvPr id="30" name="Text 23"/>
           <p:cNvSpPr txBox="1"/>
           <p:nvPr/>
         </p:nvSpPr>
@@ -31102,13 +31141,13 @@
             <a:r>
               <a:rPr lang="en-US" sz="1100" dirty="0">
                 <a:solidFill>
-                  <a:srgbClr val="EADFCB"/>
-                </a:solidFill>
-                <a:latin typeface="Yu Gothic" pitchFamily="34" charset="0"/>
-                <a:ea typeface="Yu Gothic" pitchFamily="34" charset="-122"/>
-                <a:cs typeface="Yu Gothic" pitchFamily="34" charset="-120"/>
-              </a:rPr>
-              <a:t>ファイナンシャル・プランニングの視点で、住宅と家計・老後資金をまとめてご相談いただけます。</a:t>
+                  <a:srgbClr val="C9D0DA"/>
+                </a:solidFill>
+                <a:latin typeface="Yu Gothic" pitchFamily="34" charset="0"/>
+                <a:ea typeface="Yu Gothic" pitchFamily="34" charset="-122"/>
+                <a:cs typeface="Yu Gothic" pitchFamily="34" charset="-120"/>
+              </a:rPr>
+              <a:t>営業時間 平日 11:00〜19:00／土日祝 10:00〜20:00　定休日 毎週水曜日・隔週火曜日　担当：＿＿＿＿＿＿</a:t>
             </a:r>
             <a:endParaRPr lang="en-US" sz="1100" dirty="0"/>
           </a:p>
@@ -31116,7 +31155,7 @@
       </p:sp>
       <p:sp>
         <p:nvSpPr>
-          <p:cNvPr id="30" name="Text 23"/>
+          <p:cNvPr id="31" name="Text 24"/>
           <p:cNvSpPr txBox="1"/>
           <p:nvPr/>
         </p:nvSpPr>

</xml_diff>